<commit_message>
Replace UniNav achievement summary with four-dataset ATE results
</commit_message>
<xml_diff>
--- a/presentations/uninav_research_inspiration_cn.pptx
+++ b/presentations/uninav_research_inspiration_cn.pptx
@@ -512,7 +512,7 @@
           </a:p>
           <a:p>
             <a:r>
-              <a:t>表1：Full/Fast两个变体合看在RECON、SaCSoN、GO Stanford、SCAND四基准分别取得表中最佳ATE，不代表Full独自全部最佳，也不代表RPE全部最佳。RECON strongest baseline NWM ATE .326，Full .314，下降(.326-.314)/.326=3.68%。这只是论文设置下的结果，不能证明某一模块单独的因果贡献。表1仅使用带轨迹标签的导航数据，未额外加入视频数据。</a:t>
+              <a:t>表1：Full/Fast两个变体合看在RECON、SaCSoN、GO Stanford、SCAND四基准分别取得表中最佳ATE，不代表Full独自全部最佳，也不代表RPE全部最佳。RECON strongest baseline NWM ATE .326，Full .314，下降(.326-.314)/.326=3.68%。这只是论文设置下的结果，不能证明某一模块单独的因果贡献。表1仅使用带轨迹标签的导航数据，未额外加入视频数据。新增四行表：RECON .326(NWM)→.314(Full), 3.7%；SaCSoN .616(ViNT)→.464(Full), 24.7%；GO Stanford .840(NavDP)→.687(Fast), 18.2%；SCAND .497(NWM)→.463(Full), 6.8%。百分比按原表精度四舍五入。</a:t>
             </a:r>
           </a:p>
           <a:p>
@@ -4432,8 +4432,8 @@
         </p:nvSpPr>
         <p:spPr>
           <a:xfrm>
-            <a:off x="667512" y="3035808"/>
-            <a:ext cx="3401568" cy="2560320"/>
+            <a:off x="667512" y="3017520"/>
+            <a:ext cx="5760720" cy="2587752"/>
           </a:xfrm>
           <a:prstGeom prst="roundRect">
             <a:avLst>
@@ -4472,14 +4472,970 @@
       </p:sp>
       <p:sp>
         <p:nvSpPr>
-          <p:cNvPr id="24" name="Rounded Rectangle 23"/>
+          <p:cNvPr id="24" name="TextBox 23"/>
+          <p:cNvSpPr txBox="1"/>
+          <p:nvPr/>
+        </p:nvSpPr>
+        <p:spPr>
+          <a:xfrm>
+            <a:off x="841248" y="3172968"/>
+            <a:ext cx="5394960" cy="292608"/>
+          </a:xfrm>
+          <a:prstGeom prst="rect">
+            <a:avLst/>
+          </a:prstGeom>
+          <a:noFill/>
+          <a:effectLst/>
+        </p:spPr>
+        <p:txBody>
+          <a:bodyPr wrap="none" lIns="0" rIns="0" tIns="0" bIns="0">
+            <a:spAutoFit/>
+          </a:bodyPr>
+          <a:lstStyle/>
+          <a:p>
+            <a:pPr>
+              <a:spcAft>
+                <a:spcPts val="700"/>
+              </a:spcAft>
+              <a:defRPr sz="1700" b="1">
+                <a:solidFill>
+                  <a:srgbClr val="142B46"/>
+                </a:solidFill>
+                <a:latin typeface="Noto Sans CJK SC"/>
+              </a:defRPr>
+            </a:pPr>
+            <a:r>
+              <a:t>01  四个数据集的 ATE 均优于最强对照</a:t>
+            </a:r>
+          </a:p>
+        </p:txBody>
+      </p:sp>
+      <p:sp>
+        <p:nvSpPr>
+          <p:cNvPr id="25" name="TextBox 24"/>
+          <p:cNvSpPr txBox="1"/>
+          <p:nvPr/>
+        </p:nvSpPr>
+        <p:spPr>
+          <a:xfrm>
+            <a:off x="841248" y="3575304"/>
+            <a:ext cx="5394960" cy="228600"/>
+          </a:xfrm>
+          <a:prstGeom prst="rect">
+            <a:avLst/>
+          </a:prstGeom>
+          <a:noFill/>
+          <a:effectLst/>
+        </p:spPr>
+        <p:txBody>
+          <a:bodyPr wrap="none" lIns="0" rIns="0" tIns="0" bIns="0">
+            <a:spAutoFit/>
+          </a:bodyPr>
+          <a:lstStyle/>
+          <a:p>
+            <a:pPr>
+              <a:spcAft>
+                <a:spcPts val="700"/>
+              </a:spcAft>
+              <a:defRPr sz="1000" b="0">
+                <a:solidFill>
+                  <a:srgbClr val="62748A"/>
+                </a:solidFill>
+                <a:latin typeface="Noto Sans CJK SC"/>
+              </a:defRPr>
+            </a:pPr>
+            <a:r>
+              <a:t>ATE：绝对轨迹误差，衡量预测与真实轨迹的差距，越低越好。</a:t>
+            </a:r>
+          </a:p>
+        </p:txBody>
+      </p:sp>
+      <p:sp>
+        <p:nvSpPr>
+          <p:cNvPr id="26" name="TextBox 25"/>
+          <p:cNvSpPr txBox="1"/>
+          <p:nvPr/>
+        </p:nvSpPr>
+        <p:spPr>
+          <a:xfrm>
+            <a:off x="850392" y="3950208"/>
+            <a:ext cx="1399032" cy="219456"/>
+          </a:xfrm>
+          <a:prstGeom prst="rect">
+            <a:avLst/>
+          </a:prstGeom>
+          <a:noFill/>
+          <a:effectLst/>
+        </p:spPr>
+        <p:txBody>
+          <a:bodyPr wrap="none" lIns="0" rIns="0" tIns="0" bIns="0">
+            <a:spAutoFit/>
+          </a:bodyPr>
+          <a:lstStyle/>
+          <a:p>
+            <a:pPr>
+              <a:spcAft>
+                <a:spcPts val="700"/>
+              </a:spcAft>
+              <a:defRPr sz="1000" b="1">
+                <a:solidFill>
+                  <a:srgbClr val="142B46"/>
+                </a:solidFill>
+                <a:latin typeface="Noto Sans CJK SC"/>
+              </a:defRPr>
+            </a:pPr>
+            <a:r>
+              <a:t>数据集</a:t>
+            </a:r>
+          </a:p>
+        </p:txBody>
+      </p:sp>
+      <p:sp>
+        <p:nvSpPr>
+          <p:cNvPr id="27" name="TextBox 26"/>
+          <p:cNvSpPr txBox="1"/>
+          <p:nvPr/>
+        </p:nvSpPr>
+        <p:spPr>
+          <a:xfrm>
+            <a:off x="2304288" y="3950208"/>
+            <a:ext cx="1234440" cy="219456"/>
+          </a:xfrm>
+          <a:prstGeom prst="rect">
+            <a:avLst/>
+          </a:prstGeom>
+          <a:noFill/>
+          <a:effectLst/>
+        </p:spPr>
+        <p:txBody>
+          <a:bodyPr wrap="none" lIns="0" rIns="0" tIns="0" bIns="0">
+            <a:spAutoFit/>
+          </a:bodyPr>
+          <a:lstStyle/>
+          <a:p>
+            <a:pPr>
+              <a:spcAft>
+                <a:spcPts val="700"/>
+              </a:spcAft>
+              <a:defRPr sz="1000" b="1">
+                <a:solidFill>
+                  <a:srgbClr val="142B46"/>
+                </a:solidFill>
+                <a:latin typeface="Noto Sans CJK SC"/>
+              </a:defRPr>
+            </a:pPr>
+            <a:r>
+              <a:t>最强对照 ATE</a:t>
+            </a:r>
+          </a:p>
+        </p:txBody>
+      </p:sp>
+      <p:sp>
+        <p:nvSpPr>
+          <p:cNvPr id="28" name="TextBox 27"/>
+          <p:cNvSpPr txBox="1"/>
+          <p:nvPr/>
+        </p:nvSpPr>
+        <p:spPr>
+          <a:xfrm>
+            <a:off x="3630168" y="3950208"/>
+            <a:ext cx="1344168" cy="219456"/>
+          </a:xfrm>
+          <a:prstGeom prst="rect">
+            <a:avLst/>
+          </a:prstGeom>
+          <a:noFill/>
+          <a:effectLst/>
+        </p:spPr>
+        <p:txBody>
+          <a:bodyPr wrap="none" lIns="0" rIns="0" tIns="0" bIns="0">
+            <a:spAutoFit/>
+          </a:bodyPr>
+          <a:lstStyle/>
+          <a:p>
+            <a:pPr>
+              <a:spcAft>
+                <a:spcPts val="700"/>
+              </a:spcAft>
+              <a:defRPr sz="1000" b="1">
+                <a:solidFill>
+                  <a:srgbClr val="142B46"/>
+                </a:solidFill>
+                <a:latin typeface="Noto Sans CJK SC"/>
+              </a:defRPr>
+            </a:pPr>
+            <a:r>
+              <a:t>UniNav 最好 ATE</a:t>
+            </a:r>
+          </a:p>
+        </p:txBody>
+      </p:sp>
+      <p:sp>
+        <p:nvSpPr>
+          <p:cNvPr id="29" name="TextBox 28"/>
+          <p:cNvSpPr txBox="1"/>
+          <p:nvPr/>
+        </p:nvSpPr>
+        <p:spPr>
+          <a:xfrm>
+            <a:off x="5175504" y="3950208"/>
+            <a:ext cx="987552" cy="219456"/>
+          </a:xfrm>
+          <a:prstGeom prst="rect">
+            <a:avLst/>
+          </a:prstGeom>
+          <a:noFill/>
+          <a:effectLst/>
+        </p:spPr>
+        <p:txBody>
+          <a:bodyPr wrap="none" lIns="0" rIns="0" tIns="0" bIns="0">
+            <a:spAutoFit/>
+          </a:bodyPr>
+          <a:lstStyle/>
+          <a:p>
+            <a:pPr>
+              <a:spcAft>
+                <a:spcPts val="700"/>
+              </a:spcAft>
+              <a:defRPr sz="1000" b="1">
+                <a:solidFill>
+                  <a:srgbClr val="142B46"/>
+                </a:solidFill>
+                <a:latin typeface="Noto Sans CJK SC"/>
+              </a:defRPr>
+            </a:pPr>
+            <a:r>
+              <a:t>误差降低</a:t>
+            </a:r>
+          </a:p>
+        </p:txBody>
+      </p:sp>
+      <p:cxnSp>
+        <p:nvCxnSpPr>
+          <p:cNvPr id="30" name="Connector 29"/>
+          <p:cNvCxnSpPr/>
+          <p:nvPr/>
+        </p:nvCxnSpPr>
+        <p:spPr>
+          <a:xfrm>
+            <a:off x="841248" y="4261104"/>
+            <a:ext cx="5376672" cy="0"/>
+          </a:xfrm>
+          <a:prstGeom prst="line">
+            <a:avLst/>
+          </a:prstGeom>
+          <a:ln w="12700">
+            <a:solidFill>
+              <a:srgbClr val="DCE5EF"/>
+            </a:solidFill>
+          </a:ln>
+          <a:effectLst/>
+        </p:spPr>
+        <p:style>
+          <a:lnRef idx="2">
+            <a:schemeClr val="accent1"/>
+          </a:lnRef>
+          <a:fillRef idx="0">
+            <a:schemeClr val="accent1"/>
+          </a:fillRef>
+          <a:effectRef idx="0">
+            <a:schemeClr val="accent1"/>
+          </a:effectRef>
+          <a:fontRef idx="minor">
+            <a:schemeClr val="tx1"/>
+          </a:fontRef>
+        </p:style>
+      </p:cxnSp>
+      <p:sp>
+        <p:nvSpPr>
+          <p:cNvPr id="31" name="TextBox 30"/>
+          <p:cNvSpPr txBox="1"/>
+          <p:nvPr/>
+        </p:nvSpPr>
+        <p:spPr>
+          <a:xfrm>
+            <a:off x="850392" y="4370832"/>
+            <a:ext cx="1399032" cy="219456"/>
+          </a:xfrm>
+          <a:prstGeom prst="rect">
+            <a:avLst/>
+          </a:prstGeom>
+          <a:noFill/>
+          <a:effectLst/>
+        </p:spPr>
+        <p:txBody>
+          <a:bodyPr wrap="none" lIns="0" rIns="0" tIns="0" bIns="0">
+            <a:spAutoFit/>
+          </a:bodyPr>
+          <a:lstStyle/>
+          <a:p>
+            <a:pPr>
+              <a:spcAft>
+                <a:spcPts val="700"/>
+              </a:spcAft>
+              <a:defRPr sz="1100" b="0">
+                <a:solidFill>
+                  <a:srgbClr val="142B46"/>
+                </a:solidFill>
+                <a:latin typeface="Noto Sans CJK SC"/>
+              </a:defRPr>
+            </a:pPr>
+            <a:r>
+              <a:t>RECON</a:t>
+            </a:r>
+          </a:p>
+        </p:txBody>
+      </p:sp>
+      <p:sp>
+        <p:nvSpPr>
+          <p:cNvPr id="32" name="TextBox 31"/>
+          <p:cNvSpPr txBox="1"/>
+          <p:nvPr/>
+        </p:nvSpPr>
+        <p:spPr>
+          <a:xfrm>
+            <a:off x="2304288" y="4370832"/>
+            <a:ext cx="1234440" cy="219456"/>
+          </a:xfrm>
+          <a:prstGeom prst="rect">
+            <a:avLst/>
+          </a:prstGeom>
+          <a:noFill/>
+          <a:effectLst/>
+        </p:spPr>
+        <p:txBody>
+          <a:bodyPr wrap="none" lIns="0" rIns="0" tIns="0" bIns="0">
+            <a:spAutoFit/>
+          </a:bodyPr>
+          <a:lstStyle/>
+          <a:p>
+            <a:pPr>
+              <a:spcAft>
+                <a:spcPts val="700"/>
+              </a:spcAft>
+              <a:defRPr sz="1100" b="0">
+                <a:solidFill>
+                  <a:srgbClr val="142B46"/>
+                </a:solidFill>
+                <a:latin typeface="Noto Sans CJK SC"/>
+              </a:defRPr>
+            </a:pPr>
+            <a:r>
+              <a:t>0.326</a:t>
+            </a:r>
+          </a:p>
+        </p:txBody>
+      </p:sp>
+      <p:sp>
+        <p:nvSpPr>
+          <p:cNvPr id="33" name="TextBox 32"/>
+          <p:cNvSpPr txBox="1"/>
+          <p:nvPr/>
+        </p:nvSpPr>
+        <p:spPr>
+          <a:xfrm>
+            <a:off x="3630168" y="4370832"/>
+            <a:ext cx="1344168" cy="219456"/>
+          </a:xfrm>
+          <a:prstGeom prst="rect">
+            <a:avLst/>
+          </a:prstGeom>
+          <a:noFill/>
+          <a:effectLst/>
+        </p:spPr>
+        <p:txBody>
+          <a:bodyPr wrap="none" lIns="0" rIns="0" tIns="0" bIns="0">
+            <a:spAutoFit/>
+          </a:bodyPr>
+          <a:lstStyle/>
+          <a:p>
+            <a:pPr>
+              <a:spcAft>
+                <a:spcPts val="700"/>
+              </a:spcAft>
+              <a:defRPr sz="1100" b="1">
+                <a:solidFill>
+                  <a:srgbClr val="148D91"/>
+                </a:solidFill>
+                <a:latin typeface="Noto Sans CJK SC"/>
+              </a:defRPr>
+            </a:pPr>
+            <a:r>
+              <a:t>0.314</a:t>
+            </a:r>
+          </a:p>
+        </p:txBody>
+      </p:sp>
+      <p:sp>
+        <p:nvSpPr>
+          <p:cNvPr id="34" name="TextBox 33"/>
+          <p:cNvSpPr txBox="1"/>
+          <p:nvPr/>
+        </p:nvSpPr>
+        <p:spPr>
+          <a:xfrm>
+            <a:off x="5175504" y="4370832"/>
+            <a:ext cx="987552" cy="219456"/>
+          </a:xfrm>
+          <a:prstGeom prst="rect">
+            <a:avLst/>
+          </a:prstGeom>
+          <a:noFill/>
+          <a:effectLst/>
+        </p:spPr>
+        <p:txBody>
+          <a:bodyPr wrap="none" lIns="0" rIns="0" tIns="0" bIns="0">
+            <a:spAutoFit/>
+          </a:bodyPr>
+          <a:lstStyle/>
+          <a:p>
+            <a:pPr>
+              <a:spcAft>
+                <a:spcPts val="700"/>
+              </a:spcAft>
+              <a:defRPr sz="1100" b="1">
+                <a:solidFill>
+                  <a:srgbClr val="148D91"/>
+                </a:solidFill>
+                <a:latin typeface="Noto Sans CJK SC"/>
+              </a:defRPr>
+            </a:pPr>
+            <a:r>
+              <a:t>3.7%</a:t>
+            </a:r>
+          </a:p>
+        </p:txBody>
+      </p:sp>
+      <p:sp>
+        <p:nvSpPr>
+          <p:cNvPr id="35" name="TextBox 34"/>
+          <p:cNvSpPr txBox="1"/>
+          <p:nvPr/>
+        </p:nvSpPr>
+        <p:spPr>
+          <a:xfrm>
+            <a:off x="850392" y="4622292"/>
+            <a:ext cx="1399032" cy="219456"/>
+          </a:xfrm>
+          <a:prstGeom prst="rect">
+            <a:avLst/>
+          </a:prstGeom>
+          <a:noFill/>
+          <a:effectLst/>
+        </p:spPr>
+        <p:txBody>
+          <a:bodyPr wrap="none" lIns="0" rIns="0" tIns="0" bIns="0">
+            <a:spAutoFit/>
+          </a:bodyPr>
+          <a:lstStyle/>
+          <a:p>
+            <a:pPr>
+              <a:spcAft>
+                <a:spcPts val="700"/>
+              </a:spcAft>
+              <a:defRPr sz="1100" b="0">
+                <a:solidFill>
+                  <a:srgbClr val="142B46"/>
+                </a:solidFill>
+                <a:latin typeface="Noto Sans CJK SC"/>
+              </a:defRPr>
+            </a:pPr>
+            <a:r>
+              <a:t>SaCSoN</a:t>
+            </a:r>
+          </a:p>
+        </p:txBody>
+      </p:sp>
+      <p:sp>
+        <p:nvSpPr>
+          <p:cNvPr id="36" name="TextBox 35"/>
+          <p:cNvSpPr txBox="1"/>
+          <p:nvPr/>
+        </p:nvSpPr>
+        <p:spPr>
+          <a:xfrm>
+            <a:off x="2304288" y="4622292"/>
+            <a:ext cx="1234440" cy="219456"/>
+          </a:xfrm>
+          <a:prstGeom prst="rect">
+            <a:avLst/>
+          </a:prstGeom>
+          <a:noFill/>
+          <a:effectLst/>
+        </p:spPr>
+        <p:txBody>
+          <a:bodyPr wrap="none" lIns="0" rIns="0" tIns="0" bIns="0">
+            <a:spAutoFit/>
+          </a:bodyPr>
+          <a:lstStyle/>
+          <a:p>
+            <a:pPr>
+              <a:spcAft>
+                <a:spcPts val="700"/>
+              </a:spcAft>
+              <a:defRPr sz="1100" b="0">
+                <a:solidFill>
+                  <a:srgbClr val="142B46"/>
+                </a:solidFill>
+                <a:latin typeface="Noto Sans CJK SC"/>
+              </a:defRPr>
+            </a:pPr>
+            <a:r>
+              <a:t>0.616</a:t>
+            </a:r>
+          </a:p>
+        </p:txBody>
+      </p:sp>
+      <p:sp>
+        <p:nvSpPr>
+          <p:cNvPr id="37" name="TextBox 36"/>
+          <p:cNvSpPr txBox="1"/>
+          <p:nvPr/>
+        </p:nvSpPr>
+        <p:spPr>
+          <a:xfrm>
+            <a:off x="3630168" y="4622292"/>
+            <a:ext cx="1344168" cy="219456"/>
+          </a:xfrm>
+          <a:prstGeom prst="rect">
+            <a:avLst/>
+          </a:prstGeom>
+          <a:noFill/>
+          <a:effectLst/>
+        </p:spPr>
+        <p:txBody>
+          <a:bodyPr wrap="none" lIns="0" rIns="0" tIns="0" bIns="0">
+            <a:spAutoFit/>
+          </a:bodyPr>
+          <a:lstStyle/>
+          <a:p>
+            <a:pPr>
+              <a:spcAft>
+                <a:spcPts val="700"/>
+              </a:spcAft>
+              <a:defRPr sz="1100" b="1">
+                <a:solidFill>
+                  <a:srgbClr val="148D91"/>
+                </a:solidFill>
+                <a:latin typeface="Noto Sans CJK SC"/>
+              </a:defRPr>
+            </a:pPr>
+            <a:r>
+              <a:t>0.464</a:t>
+            </a:r>
+          </a:p>
+        </p:txBody>
+      </p:sp>
+      <p:sp>
+        <p:nvSpPr>
+          <p:cNvPr id="38" name="TextBox 37"/>
+          <p:cNvSpPr txBox="1"/>
+          <p:nvPr/>
+        </p:nvSpPr>
+        <p:spPr>
+          <a:xfrm>
+            <a:off x="5175504" y="4622292"/>
+            <a:ext cx="987552" cy="219456"/>
+          </a:xfrm>
+          <a:prstGeom prst="rect">
+            <a:avLst/>
+          </a:prstGeom>
+          <a:noFill/>
+          <a:effectLst/>
+        </p:spPr>
+        <p:txBody>
+          <a:bodyPr wrap="none" lIns="0" rIns="0" tIns="0" bIns="0">
+            <a:spAutoFit/>
+          </a:bodyPr>
+          <a:lstStyle/>
+          <a:p>
+            <a:pPr>
+              <a:spcAft>
+                <a:spcPts val="700"/>
+              </a:spcAft>
+              <a:defRPr sz="1100" b="1">
+                <a:solidFill>
+                  <a:srgbClr val="148D91"/>
+                </a:solidFill>
+                <a:latin typeface="Noto Sans CJK SC"/>
+              </a:defRPr>
+            </a:pPr>
+            <a:r>
+              <a:t>24.7%</a:t>
+            </a:r>
+          </a:p>
+        </p:txBody>
+      </p:sp>
+      <p:sp>
+        <p:nvSpPr>
+          <p:cNvPr id="39" name="TextBox 38"/>
+          <p:cNvSpPr txBox="1"/>
+          <p:nvPr/>
+        </p:nvSpPr>
+        <p:spPr>
+          <a:xfrm>
+            <a:off x="850392" y="4873752"/>
+            <a:ext cx="1399032" cy="219456"/>
+          </a:xfrm>
+          <a:prstGeom prst="rect">
+            <a:avLst/>
+          </a:prstGeom>
+          <a:noFill/>
+          <a:effectLst/>
+        </p:spPr>
+        <p:txBody>
+          <a:bodyPr wrap="none" lIns="0" rIns="0" tIns="0" bIns="0">
+            <a:spAutoFit/>
+          </a:bodyPr>
+          <a:lstStyle/>
+          <a:p>
+            <a:pPr>
+              <a:spcAft>
+                <a:spcPts val="700"/>
+              </a:spcAft>
+              <a:defRPr sz="1100" b="0">
+                <a:solidFill>
+                  <a:srgbClr val="142B46"/>
+                </a:solidFill>
+                <a:latin typeface="Noto Sans CJK SC"/>
+              </a:defRPr>
+            </a:pPr>
+            <a:r>
+              <a:t>GO Stanford</a:t>
+            </a:r>
+          </a:p>
+        </p:txBody>
+      </p:sp>
+      <p:sp>
+        <p:nvSpPr>
+          <p:cNvPr id="40" name="TextBox 39"/>
+          <p:cNvSpPr txBox="1"/>
+          <p:nvPr/>
+        </p:nvSpPr>
+        <p:spPr>
+          <a:xfrm>
+            <a:off x="2304288" y="4873752"/>
+            <a:ext cx="1234440" cy="219456"/>
+          </a:xfrm>
+          <a:prstGeom prst="rect">
+            <a:avLst/>
+          </a:prstGeom>
+          <a:noFill/>
+          <a:effectLst/>
+        </p:spPr>
+        <p:txBody>
+          <a:bodyPr wrap="none" lIns="0" rIns="0" tIns="0" bIns="0">
+            <a:spAutoFit/>
+          </a:bodyPr>
+          <a:lstStyle/>
+          <a:p>
+            <a:pPr>
+              <a:spcAft>
+                <a:spcPts val="700"/>
+              </a:spcAft>
+              <a:defRPr sz="1100" b="0">
+                <a:solidFill>
+                  <a:srgbClr val="142B46"/>
+                </a:solidFill>
+                <a:latin typeface="Noto Sans CJK SC"/>
+              </a:defRPr>
+            </a:pPr>
+            <a:r>
+              <a:t>0.840</a:t>
+            </a:r>
+          </a:p>
+        </p:txBody>
+      </p:sp>
+      <p:sp>
+        <p:nvSpPr>
+          <p:cNvPr id="41" name="TextBox 40"/>
+          <p:cNvSpPr txBox="1"/>
+          <p:nvPr/>
+        </p:nvSpPr>
+        <p:spPr>
+          <a:xfrm>
+            <a:off x="3630168" y="4873752"/>
+            <a:ext cx="1344168" cy="219456"/>
+          </a:xfrm>
+          <a:prstGeom prst="rect">
+            <a:avLst/>
+          </a:prstGeom>
+          <a:noFill/>
+          <a:effectLst/>
+        </p:spPr>
+        <p:txBody>
+          <a:bodyPr wrap="none" lIns="0" rIns="0" tIns="0" bIns="0">
+            <a:spAutoFit/>
+          </a:bodyPr>
+          <a:lstStyle/>
+          <a:p>
+            <a:pPr>
+              <a:spcAft>
+                <a:spcPts val="700"/>
+              </a:spcAft>
+              <a:defRPr sz="1100" b="1">
+                <a:solidFill>
+                  <a:srgbClr val="148D91"/>
+                </a:solidFill>
+                <a:latin typeface="Noto Sans CJK SC"/>
+              </a:defRPr>
+            </a:pPr>
+            <a:r>
+              <a:t>0.687</a:t>
+            </a:r>
+          </a:p>
+        </p:txBody>
+      </p:sp>
+      <p:sp>
+        <p:nvSpPr>
+          <p:cNvPr id="42" name="TextBox 41"/>
+          <p:cNvSpPr txBox="1"/>
+          <p:nvPr/>
+        </p:nvSpPr>
+        <p:spPr>
+          <a:xfrm>
+            <a:off x="5175504" y="4873752"/>
+            <a:ext cx="987552" cy="219456"/>
+          </a:xfrm>
+          <a:prstGeom prst="rect">
+            <a:avLst/>
+          </a:prstGeom>
+          <a:noFill/>
+          <a:effectLst/>
+        </p:spPr>
+        <p:txBody>
+          <a:bodyPr wrap="none" lIns="0" rIns="0" tIns="0" bIns="0">
+            <a:spAutoFit/>
+          </a:bodyPr>
+          <a:lstStyle/>
+          <a:p>
+            <a:pPr>
+              <a:spcAft>
+                <a:spcPts val="700"/>
+              </a:spcAft>
+              <a:defRPr sz="1100" b="1">
+                <a:solidFill>
+                  <a:srgbClr val="148D91"/>
+                </a:solidFill>
+                <a:latin typeface="Noto Sans CJK SC"/>
+              </a:defRPr>
+            </a:pPr>
+            <a:r>
+              <a:t>18.2%</a:t>
+            </a:r>
+          </a:p>
+        </p:txBody>
+      </p:sp>
+      <p:sp>
+        <p:nvSpPr>
+          <p:cNvPr id="43" name="TextBox 42"/>
+          <p:cNvSpPr txBox="1"/>
+          <p:nvPr/>
+        </p:nvSpPr>
+        <p:spPr>
+          <a:xfrm>
+            <a:off x="850392" y="5125212"/>
+            <a:ext cx="1399032" cy="219456"/>
+          </a:xfrm>
+          <a:prstGeom prst="rect">
+            <a:avLst/>
+          </a:prstGeom>
+          <a:noFill/>
+          <a:effectLst/>
+        </p:spPr>
+        <p:txBody>
+          <a:bodyPr wrap="none" lIns="0" rIns="0" tIns="0" bIns="0">
+            <a:spAutoFit/>
+          </a:bodyPr>
+          <a:lstStyle/>
+          <a:p>
+            <a:pPr>
+              <a:spcAft>
+                <a:spcPts val="700"/>
+              </a:spcAft>
+              <a:defRPr sz="1100" b="0">
+                <a:solidFill>
+                  <a:srgbClr val="142B46"/>
+                </a:solidFill>
+                <a:latin typeface="Noto Sans CJK SC"/>
+              </a:defRPr>
+            </a:pPr>
+            <a:r>
+              <a:t>SCAND</a:t>
+            </a:r>
+          </a:p>
+        </p:txBody>
+      </p:sp>
+      <p:sp>
+        <p:nvSpPr>
+          <p:cNvPr id="44" name="TextBox 43"/>
+          <p:cNvSpPr txBox="1"/>
+          <p:nvPr/>
+        </p:nvSpPr>
+        <p:spPr>
+          <a:xfrm>
+            <a:off x="2304288" y="5125212"/>
+            <a:ext cx="1234440" cy="219456"/>
+          </a:xfrm>
+          <a:prstGeom prst="rect">
+            <a:avLst/>
+          </a:prstGeom>
+          <a:noFill/>
+          <a:effectLst/>
+        </p:spPr>
+        <p:txBody>
+          <a:bodyPr wrap="none" lIns="0" rIns="0" tIns="0" bIns="0">
+            <a:spAutoFit/>
+          </a:bodyPr>
+          <a:lstStyle/>
+          <a:p>
+            <a:pPr>
+              <a:spcAft>
+                <a:spcPts val="700"/>
+              </a:spcAft>
+              <a:defRPr sz="1100" b="0">
+                <a:solidFill>
+                  <a:srgbClr val="142B46"/>
+                </a:solidFill>
+                <a:latin typeface="Noto Sans CJK SC"/>
+              </a:defRPr>
+            </a:pPr>
+            <a:r>
+              <a:t>0.497</a:t>
+            </a:r>
+          </a:p>
+        </p:txBody>
+      </p:sp>
+      <p:sp>
+        <p:nvSpPr>
+          <p:cNvPr id="45" name="TextBox 44"/>
+          <p:cNvSpPr txBox="1"/>
+          <p:nvPr/>
+        </p:nvSpPr>
+        <p:spPr>
+          <a:xfrm>
+            <a:off x="3630168" y="5125212"/>
+            <a:ext cx="1344168" cy="219456"/>
+          </a:xfrm>
+          <a:prstGeom prst="rect">
+            <a:avLst/>
+          </a:prstGeom>
+          <a:noFill/>
+          <a:effectLst/>
+        </p:spPr>
+        <p:txBody>
+          <a:bodyPr wrap="none" lIns="0" rIns="0" tIns="0" bIns="0">
+            <a:spAutoFit/>
+          </a:bodyPr>
+          <a:lstStyle/>
+          <a:p>
+            <a:pPr>
+              <a:spcAft>
+                <a:spcPts val="700"/>
+              </a:spcAft>
+              <a:defRPr sz="1100" b="1">
+                <a:solidFill>
+                  <a:srgbClr val="148D91"/>
+                </a:solidFill>
+                <a:latin typeface="Noto Sans CJK SC"/>
+              </a:defRPr>
+            </a:pPr>
+            <a:r>
+              <a:t>0.463</a:t>
+            </a:r>
+          </a:p>
+        </p:txBody>
+      </p:sp>
+      <p:sp>
+        <p:nvSpPr>
+          <p:cNvPr id="46" name="TextBox 45"/>
+          <p:cNvSpPr txBox="1"/>
+          <p:nvPr/>
+        </p:nvSpPr>
+        <p:spPr>
+          <a:xfrm>
+            <a:off x="5175504" y="5125212"/>
+            <a:ext cx="987552" cy="219456"/>
+          </a:xfrm>
+          <a:prstGeom prst="rect">
+            <a:avLst/>
+          </a:prstGeom>
+          <a:noFill/>
+          <a:effectLst/>
+        </p:spPr>
+        <p:txBody>
+          <a:bodyPr wrap="none" lIns="0" rIns="0" tIns="0" bIns="0">
+            <a:spAutoFit/>
+          </a:bodyPr>
+          <a:lstStyle/>
+          <a:p>
+            <a:pPr>
+              <a:spcAft>
+                <a:spcPts val="700"/>
+              </a:spcAft>
+              <a:defRPr sz="1100" b="1">
+                <a:solidFill>
+                  <a:srgbClr val="148D91"/>
+                </a:solidFill>
+                <a:latin typeface="Noto Sans CJK SC"/>
+              </a:defRPr>
+            </a:pPr>
+            <a:r>
+              <a:t>6.8%</a:t>
+            </a:r>
+          </a:p>
+        </p:txBody>
+      </p:sp>
+      <p:sp>
+        <p:nvSpPr>
+          <p:cNvPr id="47" name="TextBox 46"/>
+          <p:cNvSpPr txBox="1"/>
+          <p:nvPr/>
+        </p:nvSpPr>
+        <p:spPr>
+          <a:xfrm>
+            <a:off x="850392" y="5431536"/>
+            <a:ext cx="5367528" cy="146304"/>
+          </a:xfrm>
+          <a:prstGeom prst="rect">
+            <a:avLst/>
+          </a:prstGeom>
+          <a:noFill/>
+          <a:effectLst/>
+        </p:spPr>
+        <p:txBody>
+          <a:bodyPr wrap="none" lIns="0" rIns="0" tIns="0" bIns="0">
+            <a:spAutoFit/>
+          </a:bodyPr>
+          <a:lstStyle/>
+          <a:p>
+            <a:pPr>
+              <a:spcAft>
+                <a:spcPts val="700"/>
+              </a:spcAft>
+              <a:defRPr sz="800" b="0">
+                <a:solidFill>
+                  <a:srgbClr val="62748A"/>
+                </a:solidFill>
+                <a:latin typeface="Noto Sans CJK SC"/>
+              </a:defRPr>
+            </a:pPr>
+            <a:r>
+              <a:t>最好值：GO Stanford 为 Fast，其余为 Full；最强对照取论文表 1 各列最优值。</a:t>
+            </a:r>
+          </a:p>
+        </p:txBody>
+      </p:sp>
+      <p:sp>
+        <p:nvSpPr>
+          <p:cNvPr id="48" name="Rounded Rectangle 47"/>
           <p:cNvSpPr/>
           <p:nvPr/>
         </p:nvSpPr>
         <p:spPr>
           <a:xfrm>
-            <a:off x="4270248" y="3035808"/>
-            <a:ext cx="3401568" cy="2560320"/>
+            <a:off x="6629400" y="3017520"/>
+            <a:ext cx="4892040" cy="1197864"/>
           </a:xfrm>
           <a:prstGeom prst="roundRect">
             <a:avLst>
@@ -4518,14 +5474,134 @@
       </p:sp>
       <p:sp>
         <p:nvSpPr>
-          <p:cNvPr id="25" name="Rounded Rectangle 24"/>
+          <p:cNvPr id="49" name="TextBox 48"/>
+          <p:cNvSpPr txBox="1"/>
+          <p:nvPr/>
+        </p:nvSpPr>
+        <p:spPr>
+          <a:xfrm>
+            <a:off x="6803136" y="3172968"/>
+            <a:ext cx="4535424" cy="274320"/>
+          </a:xfrm>
+          <a:prstGeom prst="rect">
+            <a:avLst/>
+          </a:prstGeom>
+          <a:noFill/>
+          <a:effectLst/>
+        </p:spPr>
+        <p:txBody>
+          <a:bodyPr wrap="none" lIns="0" rIns="0" tIns="0" bIns="0">
+            <a:spAutoFit/>
+          </a:bodyPr>
+          <a:lstStyle/>
+          <a:p>
+            <a:pPr>
+              <a:spcAft>
+                <a:spcPts val="700"/>
+              </a:spcAft>
+              <a:defRPr sz="1600" b="1">
+                <a:solidFill>
+                  <a:srgbClr val="142B46"/>
+                </a:solidFill>
+                <a:latin typeface="Noto Sans CJK SC"/>
+              </a:defRPr>
+            </a:pPr>
+            <a:r>
+              <a:t>02  特点：环境与动作，放在一起学</a:t>
+            </a:r>
+          </a:p>
+        </p:txBody>
+      </p:sp>
+      <p:sp>
+        <p:nvSpPr>
+          <p:cNvPr id="50" name="TextBox 49"/>
+          <p:cNvSpPr txBox="1"/>
+          <p:nvPr/>
+        </p:nvSpPr>
+        <p:spPr>
+          <a:xfrm>
+            <a:off x="6803136" y="3602736"/>
+            <a:ext cx="4535424" cy="237744"/>
+          </a:xfrm>
+          <a:prstGeom prst="rect">
+            <a:avLst/>
+          </a:prstGeom>
+          <a:noFill/>
+          <a:effectLst/>
+        </p:spPr>
+        <p:txBody>
+          <a:bodyPr wrap="none" lIns="0" rIns="0" tIns="0" bIns="0">
+            <a:spAutoFit/>
+          </a:bodyPr>
+          <a:lstStyle/>
+          <a:p>
+            <a:pPr>
+              <a:spcAft>
+                <a:spcPts val="700"/>
+              </a:spcAft>
+              <a:defRPr sz="1100" b="0">
+                <a:solidFill>
+                  <a:srgbClr val="62748A"/>
+                </a:solidFill>
+                <a:latin typeface="Noto Sans CJK SC"/>
+              </a:defRPr>
+            </a:pPr>
+            <a:r>
+              <a:t>未来画面、轨迹和几何表征共享网络，接受各自监督。</a:t>
+            </a:r>
+          </a:p>
+        </p:txBody>
+      </p:sp>
+      <p:sp>
+        <p:nvSpPr>
+          <p:cNvPr id="51" name="TextBox 50"/>
+          <p:cNvSpPr txBox="1"/>
+          <p:nvPr/>
+        </p:nvSpPr>
+        <p:spPr>
+          <a:xfrm>
+            <a:off x="6803136" y="3922776"/>
+            <a:ext cx="4535424" cy="219456"/>
+          </a:xfrm>
+          <a:prstGeom prst="rect">
+            <a:avLst/>
+          </a:prstGeom>
+          <a:noFill/>
+          <a:effectLst/>
+        </p:spPr>
+        <p:txBody>
+          <a:bodyPr wrap="none" lIns="0" rIns="0" tIns="0" bIns="0">
+            <a:spAutoFit/>
+          </a:bodyPr>
+          <a:lstStyle/>
+          <a:p>
+            <a:pPr>
+              <a:spcAft>
+                <a:spcPts val="700"/>
+              </a:spcAft>
+              <a:defRPr sz="1100" b="0">
+                <a:solidFill>
+                  <a:srgbClr val="62748A"/>
+                </a:solidFill>
+                <a:latin typeface="Noto Sans CJK SC"/>
+              </a:defRPr>
+            </a:pPr>
+            <a:r>
+              <a:t>Fast 经专门训练，在推理时省去未来画面生成。</a:t>
+            </a:r>
+          </a:p>
+        </p:txBody>
+      </p:sp>
+      <p:sp>
+        <p:nvSpPr>
+          <p:cNvPr id="52" name="Rounded Rectangle 51"/>
           <p:cNvSpPr/>
           <p:nvPr/>
         </p:nvSpPr>
         <p:spPr>
           <a:xfrm>
-            <a:off x="7872983" y="3035808"/>
-            <a:ext cx="3648456" cy="2560320"/>
+            <a:off x="6629400" y="4407408"/>
+            <a:ext cx="4892040" cy="1197864"/>
           </a:xfrm>
           <a:prstGeom prst="roundRect">
             <a:avLst>
@@ -4564,14 +5640,14 @@
       </p:sp>
       <p:sp>
         <p:nvSpPr>
-          <p:cNvPr id="26" name="TextBox 25"/>
+          <p:cNvPr id="53" name="TextBox 52"/>
           <p:cNvSpPr txBox="1"/>
           <p:nvPr/>
         </p:nvSpPr>
         <p:spPr>
           <a:xfrm>
-            <a:off x="841248" y="3209544"/>
-            <a:ext cx="3017520" cy="292608"/>
+            <a:off x="6803136" y="4562856"/>
+            <a:ext cx="4535424" cy="274320"/>
           </a:xfrm>
           <a:prstGeom prst="rect">
             <a:avLst/>
@@ -4589,7 +5665,7 @@
               <a:spcAft>
                 <a:spcPts val="700"/>
               </a:spcAft>
-              <a:defRPr sz="1800" b="1">
+              <a:defRPr sz="1500" b="1">
                 <a:solidFill>
                   <a:srgbClr val="142B46"/>
                 </a:solidFill>
@@ -4597,21 +5673,21 @@
               </a:defRPr>
             </a:pPr>
             <a:r>
-              <a:t>01  取得了什么？</a:t>
-            </a:r>
-          </a:p>
-        </p:txBody>
-      </p:sp>
-      <p:sp>
-        <p:nvSpPr>
-          <p:cNvPr id="27" name="TextBox 26"/>
+              <a:t>03  启发：不只监督终点，也监督运动过程</a:t>
+            </a:r>
+          </a:p>
+        </p:txBody>
+      </p:sp>
+      <p:sp>
+        <p:nvSpPr>
+          <p:cNvPr id="54" name="TextBox 53"/>
           <p:cNvSpPr txBox="1"/>
           <p:nvPr/>
         </p:nvSpPr>
         <p:spPr>
           <a:xfrm>
-            <a:off x="841248" y="3666744"/>
-            <a:ext cx="3017520" cy="292608"/>
+            <a:off x="6803136" y="4992624"/>
+            <a:ext cx="4535424" cy="228600"/>
           </a:xfrm>
           <a:prstGeom prst="rect">
             <a:avLst/>
@@ -4629,7 +5705,47 @@
               <a:spcAft>
                 <a:spcPts val="700"/>
               </a:spcAft>
-              <a:defRPr sz="1500" b="1">
+              <a:defRPr sz="1100" b="0">
+                <a:solidFill>
+                  <a:srgbClr val="62748A"/>
+                </a:solidFill>
+                <a:latin typeface="Noto Sans CJK SC"/>
+              </a:defRPr>
+            </a:pPr>
+            <a:r>
+              <a:t>可加入逐步转角辅助任务，让视觉特征学习途中转弯。</a:t>
+            </a:r>
+          </a:p>
+        </p:txBody>
+      </p:sp>
+      <p:sp>
+        <p:nvSpPr>
+          <p:cNvPr id="55" name="TextBox 54"/>
+          <p:cNvSpPr txBox="1"/>
+          <p:nvPr/>
+        </p:nvSpPr>
+        <p:spPr>
+          <a:xfrm>
+            <a:off x="6803136" y="5312664"/>
+            <a:ext cx="4535424" cy="219456"/>
+          </a:xfrm>
+          <a:prstGeom prst="rect">
+            <a:avLst/>
+          </a:prstGeom>
+          <a:noFill/>
+          <a:effectLst/>
+        </p:spPr>
+        <p:txBody>
+          <a:bodyPr wrap="none" lIns="0" rIns="0" tIns="0" bIns="0">
+            <a:spAutoFit/>
+          </a:bodyPr>
+          <a:lstStyle/>
+          <a:p>
+            <a:pPr>
+              <a:spcAft>
+                <a:spcPts val="700"/>
+              </a:spcAft>
+              <a:defRPr sz="1100" b="1">
                 <a:solidFill>
                   <a:srgbClr val="148D91"/>
                 </a:solidFill>
@@ -4637,582 +5753,14 @@
               </a:defRPr>
             </a:pPr>
             <a:r>
-              <a:t>四个基准，轨迹误差更低</a:t>
-            </a:r>
-          </a:p>
-        </p:txBody>
-      </p:sp>
-      <p:sp>
-        <p:nvSpPr>
-          <p:cNvPr id="28" name="TextBox 27"/>
-          <p:cNvSpPr txBox="1"/>
-          <p:nvPr/>
-        </p:nvSpPr>
-        <p:spPr>
-          <a:xfrm>
-            <a:off x="841248" y="4069080"/>
-            <a:ext cx="3063240" cy="566928"/>
-          </a:xfrm>
-          <a:prstGeom prst="rect">
-            <a:avLst/>
-          </a:prstGeom>
-          <a:noFill/>
-          <a:effectLst/>
-        </p:spPr>
-        <p:txBody>
-          <a:bodyPr wrap="none" lIns="0" rIns="0" tIns="0" bIns="0">
-            <a:spAutoFit/>
-          </a:bodyPr>
-          <a:lstStyle/>
-          <a:p>
-            <a:pPr>
-              <a:spcAft>
-                <a:spcPts val="700"/>
-              </a:spcAft>
-              <a:defRPr sz="1200" b="0">
-                <a:solidFill>
-                  <a:srgbClr val="62748A"/>
-                </a:solidFill>
-                <a:latin typeface="Noto Sans CJK SC"/>
-              </a:defRPr>
-            </a:pPr>
-            <a:r>
-              <a:t>Full / Fast 在四个数据集上</a:t>
-            </a:r>
-          </a:p>
-          <a:p>
-            <a:pPr>
-              <a:spcAft>
-                <a:spcPts val="700"/>
-              </a:spcAft>
-              <a:defRPr sz="1200" b="0">
-                <a:solidFill>
-                  <a:srgbClr val="62748A"/>
-                </a:solidFill>
-                <a:latin typeface="Noto Sans CJK SC"/>
-              </a:defRPr>
-            </a:pPr>
-            <a:r>
-              <a:t>取得表中最佳绝对轨迹误差。</a:t>
-            </a:r>
-          </a:p>
-        </p:txBody>
-      </p:sp>
-      <p:sp>
-        <p:nvSpPr>
-          <p:cNvPr id="29" name="TextBox 28"/>
-          <p:cNvSpPr txBox="1"/>
-          <p:nvPr/>
-        </p:nvSpPr>
-        <p:spPr>
-          <a:xfrm>
-            <a:off x="841248" y="4727448"/>
-            <a:ext cx="3063240" cy="265176"/>
-          </a:xfrm>
-          <a:prstGeom prst="rect">
-            <a:avLst/>
-          </a:prstGeom>
-          <a:noFill/>
-          <a:effectLst/>
-        </p:spPr>
-        <p:txBody>
-          <a:bodyPr wrap="none" lIns="0" rIns="0" tIns="0" bIns="0">
-            <a:spAutoFit/>
-          </a:bodyPr>
-          <a:lstStyle/>
-          <a:p>
-            <a:pPr>
-              <a:spcAft>
-                <a:spcPts val="700"/>
-              </a:spcAft>
-              <a:defRPr sz="1200" b="1">
-                <a:solidFill>
-                  <a:srgbClr val="142B46"/>
-                </a:solidFill>
-                <a:latin typeface="Noto Sans CJK SC"/>
-              </a:defRPr>
-            </a:pPr>
-            <a:r>
-              <a:t>RECON：Full 的误差降低 3.7%</a:t>
-            </a:r>
-          </a:p>
-        </p:txBody>
-      </p:sp>
-      <p:sp>
-        <p:nvSpPr>
-          <p:cNvPr id="30" name="TextBox 29"/>
-          <p:cNvSpPr txBox="1"/>
-          <p:nvPr/>
-        </p:nvSpPr>
-        <p:spPr>
-          <a:xfrm>
-            <a:off x="841248" y="5065776"/>
-            <a:ext cx="3063240" cy="274320"/>
-          </a:xfrm>
-          <a:prstGeom prst="rect">
-            <a:avLst/>
-          </a:prstGeom>
-          <a:noFill/>
-          <a:effectLst/>
-        </p:spPr>
-        <p:txBody>
-          <a:bodyPr wrap="none" lIns="0" rIns="0" tIns="0" bIns="0">
-            <a:spAutoFit/>
-          </a:bodyPr>
-          <a:lstStyle/>
-          <a:p>
-            <a:pPr>
-              <a:spcAft>
-                <a:spcPts val="700"/>
-              </a:spcAft>
-              <a:defRPr sz="1100" b="1">
-                <a:solidFill>
-                  <a:srgbClr val="142B46"/>
-                </a:solidFill>
-                <a:latin typeface="Noto Sans CJK SC"/>
-              </a:defRPr>
-            </a:pPr>
-            <a:r>
-              <a:t>同为两步，Fast 比 Full 快约 1.8 倍</a:t>
-            </a:r>
-          </a:p>
-        </p:txBody>
-      </p:sp>
-      <p:sp>
-        <p:nvSpPr>
-          <p:cNvPr id="31" name="TextBox 30"/>
-          <p:cNvSpPr txBox="1"/>
-          <p:nvPr/>
-        </p:nvSpPr>
-        <p:spPr>
-          <a:xfrm>
-            <a:off x="4443984" y="3209544"/>
-            <a:ext cx="3017520" cy="292608"/>
-          </a:xfrm>
-          <a:prstGeom prst="rect">
-            <a:avLst/>
-          </a:prstGeom>
-          <a:noFill/>
-          <a:effectLst/>
-        </p:spPr>
-        <p:txBody>
-          <a:bodyPr wrap="none" lIns="0" rIns="0" tIns="0" bIns="0">
-            <a:spAutoFit/>
-          </a:bodyPr>
-          <a:lstStyle/>
-          <a:p>
-            <a:pPr>
-              <a:spcAft>
-                <a:spcPts val="700"/>
-              </a:spcAft>
-              <a:defRPr sz="1800" b="1">
-                <a:solidFill>
-                  <a:srgbClr val="142B46"/>
-                </a:solidFill>
-                <a:latin typeface="Noto Sans CJK SC"/>
-              </a:defRPr>
-            </a:pPr>
-            <a:r>
-              <a:t>02  有什么特点？</a:t>
-            </a:r>
-          </a:p>
-        </p:txBody>
-      </p:sp>
-      <p:sp>
-        <p:nvSpPr>
-          <p:cNvPr id="32" name="TextBox 31"/>
-          <p:cNvSpPr txBox="1"/>
-          <p:nvPr/>
-        </p:nvSpPr>
-        <p:spPr>
-          <a:xfrm>
-            <a:off x="4443984" y="3666744"/>
-            <a:ext cx="3017520" cy="274320"/>
-          </a:xfrm>
-          <a:prstGeom prst="rect">
-            <a:avLst/>
-          </a:prstGeom>
-          <a:noFill/>
-          <a:effectLst/>
-        </p:spPr>
-        <p:txBody>
-          <a:bodyPr wrap="none" lIns="0" rIns="0" tIns="0" bIns="0">
-            <a:spAutoFit/>
-          </a:bodyPr>
-          <a:lstStyle/>
-          <a:p>
-            <a:pPr>
-              <a:spcAft>
-                <a:spcPts val="700"/>
-              </a:spcAft>
-              <a:defRPr sz="1500" b="1">
-                <a:solidFill>
-                  <a:srgbClr val="148D91"/>
-                </a:solidFill>
-                <a:latin typeface="Noto Sans CJK SC"/>
-              </a:defRPr>
-            </a:pPr>
-            <a:r>
-              <a:t>环境与动作，放在一起学</a:t>
-            </a:r>
-          </a:p>
-        </p:txBody>
-      </p:sp>
-      <p:sp>
-        <p:nvSpPr>
-          <p:cNvPr id="33" name="TextBox 32"/>
-          <p:cNvSpPr txBox="1"/>
-          <p:nvPr/>
-        </p:nvSpPr>
-        <p:spPr>
-          <a:xfrm>
-            <a:off x="4443984" y="4087368"/>
-            <a:ext cx="3063240" cy="502920"/>
-          </a:xfrm>
-          <a:prstGeom prst="rect">
-            <a:avLst/>
-          </a:prstGeom>
-          <a:noFill/>
-          <a:effectLst/>
-        </p:spPr>
-        <p:txBody>
-          <a:bodyPr wrap="none" lIns="0" rIns="0" tIns="0" bIns="0">
-            <a:spAutoFit/>
-          </a:bodyPr>
-          <a:lstStyle/>
-          <a:p>
-            <a:pPr>
-              <a:spcAft>
-                <a:spcPts val="700"/>
-              </a:spcAft>
-              <a:defRPr sz="1200" b="0">
-                <a:solidFill>
-                  <a:srgbClr val="62748A"/>
-                </a:solidFill>
-                <a:latin typeface="Noto Sans CJK SC"/>
-              </a:defRPr>
-            </a:pPr>
-            <a:r>
-              <a:t>未来画面、轨迹、几何表征</a:t>
-            </a:r>
-          </a:p>
-          <a:p>
-            <a:pPr>
-              <a:spcAft>
-                <a:spcPts val="700"/>
-              </a:spcAft>
-              <a:defRPr sz="1200" b="0">
-                <a:solidFill>
-                  <a:srgbClr val="62748A"/>
-                </a:solidFill>
-                <a:latin typeface="Noto Sans CJK SC"/>
-              </a:defRPr>
-            </a:pPr>
-            <a:r>
-              <a:t>共享网络，接受各自的监督。</a:t>
-            </a:r>
-          </a:p>
-        </p:txBody>
-      </p:sp>
-      <p:sp>
-        <p:nvSpPr>
-          <p:cNvPr id="34" name="TextBox 33"/>
-          <p:cNvSpPr txBox="1"/>
-          <p:nvPr/>
-        </p:nvSpPr>
-        <p:spPr>
-          <a:xfrm>
-            <a:off x="4443984" y="4727448"/>
-            <a:ext cx="3017520" cy="265176"/>
-          </a:xfrm>
-          <a:prstGeom prst="rect">
-            <a:avLst/>
-          </a:prstGeom>
-          <a:noFill/>
-          <a:effectLst/>
-        </p:spPr>
-        <p:txBody>
-          <a:bodyPr wrap="none" lIns="0" rIns="0" tIns="0" bIns="0">
-            <a:spAutoFit/>
-          </a:bodyPr>
-          <a:lstStyle/>
-          <a:p>
-            <a:pPr>
-              <a:spcAft>
-                <a:spcPts val="700"/>
-              </a:spcAft>
-              <a:defRPr sz="1300" b="1">
-                <a:solidFill>
-                  <a:srgbClr val="142B46"/>
-                </a:solidFill>
-                <a:latin typeface="Noto Sans CJK SC"/>
-              </a:defRPr>
-            </a:pPr>
-            <a:r>
-              <a:t>训练学得丰富，推理可以精简</a:t>
-            </a:r>
-          </a:p>
-        </p:txBody>
-      </p:sp>
-      <p:sp>
-        <p:nvSpPr>
-          <p:cNvPr id="35" name="TextBox 34"/>
-          <p:cNvSpPr txBox="1"/>
-          <p:nvPr/>
-        </p:nvSpPr>
-        <p:spPr>
-          <a:xfrm>
-            <a:off x="4443984" y="5074920"/>
-            <a:ext cx="3063240" cy="265176"/>
-          </a:xfrm>
-          <a:prstGeom prst="rect">
-            <a:avLst/>
-          </a:prstGeom>
-          <a:noFill/>
-          <a:effectLst/>
-        </p:spPr>
-        <p:txBody>
-          <a:bodyPr wrap="none" lIns="0" rIns="0" tIns="0" bIns="0">
-            <a:spAutoFit/>
-          </a:bodyPr>
-          <a:lstStyle/>
-          <a:p>
-            <a:pPr>
-              <a:spcAft>
-                <a:spcPts val="700"/>
-              </a:spcAft>
-              <a:defRPr sz="1050" b="0">
-                <a:solidFill>
-                  <a:srgbClr val="62748A"/>
-                </a:solidFill>
-                <a:latin typeface="Noto Sans CJK SC"/>
-              </a:defRPr>
-            </a:pPr>
-            <a:r>
-              <a:t>Fast 经专门训练，省去未来画面生成。</a:t>
-            </a:r>
-          </a:p>
-        </p:txBody>
-      </p:sp>
-      <p:sp>
-        <p:nvSpPr>
-          <p:cNvPr id="36" name="TextBox 35"/>
-          <p:cNvSpPr txBox="1"/>
-          <p:nvPr/>
-        </p:nvSpPr>
-        <p:spPr>
-          <a:xfrm>
-            <a:off x="8046720" y="3209544"/>
-            <a:ext cx="3200400" cy="292608"/>
-          </a:xfrm>
-          <a:prstGeom prst="rect">
-            <a:avLst/>
-          </a:prstGeom>
-          <a:noFill/>
-          <a:effectLst/>
-        </p:spPr>
-        <p:txBody>
-          <a:bodyPr wrap="none" lIns="0" rIns="0" tIns="0" bIns="0">
-            <a:spAutoFit/>
-          </a:bodyPr>
-          <a:lstStyle/>
-          <a:p>
-            <a:pPr>
-              <a:spcAft>
-                <a:spcPts val="700"/>
-              </a:spcAft>
-              <a:defRPr sz="1800" b="1">
-                <a:solidFill>
-                  <a:srgbClr val="142B46"/>
-                </a:solidFill>
-                <a:latin typeface="Noto Sans CJK SC"/>
-              </a:defRPr>
-            </a:pPr>
-            <a:r>
-              <a:t>03  对我的启发</a:t>
-            </a:r>
-          </a:p>
-        </p:txBody>
-      </p:sp>
-      <p:sp>
-        <p:nvSpPr>
-          <p:cNvPr id="37" name="TextBox 36"/>
-          <p:cNvSpPr txBox="1"/>
-          <p:nvPr/>
-        </p:nvSpPr>
-        <p:spPr>
-          <a:xfrm>
-            <a:off x="8046720" y="3666744"/>
-            <a:ext cx="3200400" cy="274320"/>
-          </a:xfrm>
-          <a:prstGeom prst="rect">
-            <a:avLst/>
-          </a:prstGeom>
-          <a:noFill/>
-          <a:effectLst/>
-        </p:spPr>
-        <p:txBody>
-          <a:bodyPr wrap="none" lIns="0" rIns="0" tIns="0" bIns="0">
-            <a:spAutoFit/>
-          </a:bodyPr>
-          <a:lstStyle/>
-          <a:p>
-            <a:pPr>
-              <a:spcAft>
-                <a:spcPts val="700"/>
-              </a:spcAft>
-              <a:defRPr sz="1400" b="1">
-                <a:solidFill>
-                  <a:srgbClr val="148D91"/>
-                </a:solidFill>
-                <a:latin typeface="Noto Sans CJK SC"/>
-              </a:defRPr>
-            </a:pPr>
-            <a:r>
-              <a:t>不只监督终点，也监督运动过程</a:t>
-            </a:r>
-          </a:p>
-        </p:txBody>
-      </p:sp>
-      <p:sp>
-        <p:nvSpPr>
-          <p:cNvPr id="38" name="TextBox 37"/>
-          <p:cNvSpPr txBox="1"/>
-          <p:nvPr/>
-        </p:nvSpPr>
-        <p:spPr>
-          <a:xfrm>
-            <a:off x="8046720" y="4087368"/>
-            <a:ext cx="3200400" cy="566928"/>
-          </a:xfrm>
-          <a:prstGeom prst="rect">
-            <a:avLst/>
-          </a:prstGeom>
-          <a:noFill/>
-          <a:effectLst/>
-        </p:spPr>
-        <p:txBody>
-          <a:bodyPr wrap="none" lIns="0" rIns="0" tIns="0" bIns="0">
-            <a:spAutoFit/>
-          </a:bodyPr>
-          <a:lstStyle/>
-          <a:p>
-            <a:pPr>
-              <a:spcAft>
-                <a:spcPts val="700"/>
-              </a:spcAft>
-              <a:defRPr sz="1200" b="0">
-                <a:solidFill>
-                  <a:srgbClr val="62748A"/>
-                </a:solidFill>
-                <a:latin typeface="Noto Sans CJK SC"/>
-              </a:defRPr>
-            </a:pPr>
-            <a:r>
-              <a:t>可加入逐步转角等辅助任务，</a:t>
-            </a:r>
-          </a:p>
-          <a:p>
-            <a:pPr>
-              <a:spcAft>
-                <a:spcPts val="700"/>
-              </a:spcAft>
-              <a:defRPr sz="1200" b="0">
-                <a:solidFill>
-                  <a:srgbClr val="62748A"/>
-                </a:solidFill>
-                <a:latin typeface="Noto Sans CJK SC"/>
-              </a:defRPr>
-            </a:pPr>
-            <a:r>
-              <a:t>让共享视觉特征学习途中如何转弯。</a:t>
-            </a:r>
-          </a:p>
-        </p:txBody>
-      </p:sp>
-      <p:sp>
-        <p:nvSpPr>
-          <p:cNvPr id="39" name="TextBox 38"/>
-          <p:cNvSpPr txBox="1"/>
-          <p:nvPr/>
-        </p:nvSpPr>
-        <p:spPr>
-          <a:xfrm>
-            <a:off x="8046720" y="4754880"/>
-            <a:ext cx="3200400" cy="246888"/>
-          </a:xfrm>
-          <a:prstGeom prst="rect">
-            <a:avLst/>
-          </a:prstGeom>
-          <a:noFill/>
-          <a:effectLst/>
-        </p:spPr>
-        <p:txBody>
-          <a:bodyPr wrap="none" lIns="0" rIns="0" tIns="0" bIns="0">
-            <a:spAutoFit/>
-          </a:bodyPr>
-          <a:lstStyle/>
-          <a:p>
-            <a:pPr>
-              <a:spcAft>
-                <a:spcPts val="700"/>
-              </a:spcAft>
-              <a:defRPr sz="1200" b="1">
-                <a:solidFill>
-                  <a:srgbClr val="142B46"/>
-                </a:solidFill>
-                <a:latin typeface="Noto Sans CJK SC"/>
-              </a:defRPr>
-            </a:pPr>
-            <a:r>
-              <a:t>再分别验证：</a:t>
-            </a:r>
-          </a:p>
-        </p:txBody>
-      </p:sp>
-      <p:sp>
-        <p:nvSpPr>
-          <p:cNvPr id="40" name="TextBox 39"/>
-          <p:cNvSpPr txBox="1"/>
-          <p:nvPr/>
-        </p:nvSpPr>
-        <p:spPr>
-          <a:xfrm>
-            <a:off x="8046720" y="5093208"/>
-            <a:ext cx="3200400" cy="274320"/>
-          </a:xfrm>
-          <a:prstGeom prst="rect">
-            <a:avLst/>
-          </a:prstGeom>
-          <a:noFill/>
-          <a:effectLst/>
-        </p:spPr>
-        <p:txBody>
-          <a:bodyPr wrap="none" lIns="0" rIns="0" tIns="0" bIns="0">
-            <a:spAutoFit/>
-          </a:bodyPr>
-          <a:lstStyle/>
-          <a:p>
-            <a:pPr>
-              <a:spcAft>
-                <a:spcPts val="700"/>
-              </a:spcAft>
-              <a:defRPr sz="1300" b="1">
-                <a:solidFill>
-                  <a:srgbClr val="142B46"/>
-                </a:solidFill>
-                <a:latin typeface="Noto Sans CJK SC"/>
-              </a:defRPr>
-            </a:pPr>
-            <a:r>
-              <a:t>只辅助训练 / 是否用于推理</a:t>
-            </a:r>
-          </a:p>
-        </p:txBody>
-      </p:sp>
-      <p:sp>
-        <p:nvSpPr>
-          <p:cNvPr id="41" name="Rounded Rectangle 40"/>
+              <a:t>分别验证：只辅助训练 / 是否用于推理。</a:t>
+            </a:r>
+          </a:p>
+        </p:txBody>
+      </p:sp>
+      <p:sp>
+        <p:nvSpPr>
+          <p:cNvPr id="56" name="Rounded Rectangle 55"/>
           <p:cNvSpPr/>
           <p:nvPr/>
         </p:nvSpPr>
@@ -5258,7 +5806,7 @@
       </p:sp>
       <p:sp>
         <p:nvSpPr>
-          <p:cNvPr id="42" name="TextBox 41"/>
+          <p:cNvPr id="57" name="TextBox 56"/>
           <p:cNvSpPr txBox="1"/>
           <p:nvPr/>
         </p:nvSpPr>
@@ -5298,7 +5846,7 @@
       </p:sp>
       <p:sp>
         <p:nvSpPr>
-          <p:cNvPr id="43" name="TextBox 42"/>
+          <p:cNvPr id="58" name="TextBox 57"/>
           <p:cNvSpPr txBox="1"/>
           <p:nvPr/>
         </p:nvSpPr>
@@ -5338,7 +5886,7 @@
       </p:sp>
       <p:sp>
         <p:nvSpPr>
-          <p:cNvPr id="44" name="TextBox 43"/>
+          <p:cNvPr id="59" name="TextBox 58"/>
           <p:cNvSpPr txBox="1"/>
           <p:nvPr/>
         </p:nvSpPr>
@@ -5371,7 +5919,7 @@
               </a:defRPr>
             </a:pPr>
             <a:r>
-              <a:t>来源：UniNav，arXiv:2608.03244v1，图 2、表 1 / 4、§3.4 / 5。RECON 对比 NWM；速度为 RTX 4090 两步采样。</a:t>
+              <a:t>来源：UniNav，arXiv:2608.03244v1，图 2、表 1、§3.4 / 5。误差降低 =（最强对照 ATE − UniNav 最好 ATE）/ 最强对照 ATE。</a:t>
             </a:r>
           </a:p>
         </p:txBody>

</xml_diff>

<commit_message>
Clarify UniNav inspiration and add controlled future experiment plan slide
</commit_message>
<xml_diff>
--- a/presentations/uninav_research_inspiration_cn.pptx
+++ b/presentations/uninav_research_inspiration_cn.pptx
@@ -5673,7 +5673,7 @@
               </a:defRPr>
             </a:pPr>
             <a:r>
-              <a:t>03  启发：不只监督终点，也监督运动过程</a:t>
+              <a:t>03  启发：借鉴联合监督，提出待验证假设</a:t>
             </a:r>
           </a:p>
         </p:txBody>
@@ -5713,7 +5713,7 @@
               </a:defRPr>
             </a:pPr>
             <a:r>
-              <a:t>可加入逐步转角辅助任务，让视觉特征学习途中转弯。</a:t>
+              <a:t>借鉴多种未来信息共同训练的思路，尝试转角辅助任务。</a:t>
             </a:r>
           </a:p>
         </p:txBody>
@@ -5753,7 +5753,7 @@
               </a:defRPr>
             </a:pPr>
             <a:r>
-              <a:t>分别验证：只辅助训练 / 是否用于推理。</a:t>
+              <a:t>转角能否改善方向预测，需独立对照实验验证。</a:t>
             </a:r>
           </a:p>
         </p:txBody>
@@ -5839,7 +5839,7 @@
               </a:defRPr>
             </a:pPr>
             <a:r>
-              <a:t>可借鉴的是“增加未来信息的训练监督”；转角辅助任务能否改善方向预测，还需要实验检验。</a:t>
+              <a:t>论文验证的是整体方法，不能将其提升归因于转角监督；本项目仅借鉴联合监督的思路。</a:t>
             </a:r>
           </a:p>
         </p:txBody>

</xml_diff>